<commit_message>
Stage 8 review fixes: HO-002
</commit_message>
<xml_diff>
--- a/output/archive/Tarnovell_Group/Governance/Board/2024/Q2/Integration_Board_Update_v3_FINAL_final.pptx
+++ b/output/archive/Tarnovell_Group/Governance/Board/2024/Q2/Integration_Board_Update_v3_FINAL_final.pptx
@@ -8,14 +8,14 @@
     <p:sldId id="256" r:id="rId7"/>
     <p:sldId id="257" r:id="rId8"/>
     <p:sldId id="258" r:id="rId9"/>
-    <p:sldId id="259" r:id="rId11"/>
-    <p:sldId id="260" r:id="rId12"/>
-    <p:sldId id="261" r:id="rId13"/>
-    <p:sldId id="262" r:id="rId14"/>
-    <p:sldId id="263" r:id="rId15"/>
-    <p:sldId id="264" r:id="rId16"/>
-    <p:sldId id="265" r:id="rId17"/>
-    <p:sldId id="266" r:id="rId18"/>
+    <p:sldId id="259" r:id="rId10"/>
+    <p:sldId id="260" r:id="rId11"/>
+    <p:sldId id="261" r:id="rId12"/>
+    <p:sldId id="262" r:id="rId13"/>
+    <p:sldId id="263" r:id="rId14"/>
+    <p:sldId id="264" r:id="rId15"/>
+    <p:sldId id="265" r:id="rId16"/>
+    <p:sldId id="266" r:id="rId17"/>
     <p:sldId id="267" r:id="rId19"/>
     <p:sldId id="268" r:id="rId20"/>
     <p:sldId id="269" r:id="rId21"/>
@@ -471,76 +471,6 @@
 </file>
 
 <file path=ppt/notesSlides/notesSlide1.xml><?xml version="1.0" encoding="utf-8"?>
-<p:notes xmlns:a="http://schemas.openxmlformats.org/drawingml/2006/main" xmlns:p="http://schemas.openxmlformats.org/presentationml/2006/main" xmlns:r="http://schemas.openxmlformats.org/officeDocument/2006/relationships">
-  <p:cSld>
-    <p:spTree>
-      <p:nvGrpSpPr>
-        <p:cNvPr id="1" name=""/>
-        <p:cNvGrpSpPr/>
-        <p:nvPr/>
-      </p:nvGrpSpPr>
-      <p:grpSpPr>
-        <a:xfrm>
-          <a:off x="0" y="0"/>
-          <a:ext cx="0" cy="0"/>
-          <a:chOff x="0" y="0"/>
-          <a:chExt cx="0" cy="0"/>
-        </a:xfrm>
-      </p:grpSpPr>
-      <p:sp>
-        <p:nvSpPr>
-          <p:cNvPr id="2" name="Slide Image Placeholder 1"/>
-          <p:cNvSpPr>
-            <a:spLocks noGrp="1"/>
-          </p:cNvSpPr>
-          <p:nvPr>
-            <p:ph type="sldImg" idx="2"/>
-          </p:nvPr>
-        </p:nvSpPr>
-        <p:spPr/>
-      </p:sp>
-      <p:sp>
-        <p:nvSpPr>
-          <p:cNvPr id="3" name="Notes Placeholder 2"/>
-          <p:cNvSpPr>
-            <a:spLocks noGrp="1"/>
-          </p:cNvSpPr>
-          <p:nvPr>
-            <p:ph type="body" idx="3" sz="quarter"/>
-          </p:nvPr>
-        </p:nvSpPr>
-        <p:spPr/>
-        <p:txBody>
-          <a:bodyPr/>
-          <a:lstStyle/>
-          <a:p>
-            <a:r>
-              <a:t>This principle is the test for every workstream decision. Two items on today's agenda are exceptions and are flagged as such.</a:t>
-            </a:r>
-          </a:p>
-        </p:txBody>
-      </p:sp>
-      <p:sp>
-        <p:nvSpPr>
-          <p:cNvPr id="4" name="Slide Number Placeholder 3"/>
-          <p:cNvSpPr>
-            <a:spLocks noGrp="1"/>
-          </p:cNvSpPr>
-          <p:nvPr>
-            <p:ph type="sldNum" idx="5" sz="quarter"/>
-          </p:nvPr>
-        </p:nvSpPr>
-        <p:spPr/>
-      </p:sp>
-    </p:spTree>
-  </p:cSld>
-  <p:clrMapOvr>
-    <a:masterClrMapping/>
-  </p:clrMapOvr>
-</p:notes>
-</file>
-
-<file path=ppt/notesSlides/notesSlide2.xml><?xml version="1.0" encoding="utf-8"?>
 <p:notes xmlns:a="http://schemas.openxmlformats.org/drawingml/2006/main" xmlns:p="http://schemas.openxmlformats.org/presentationml/2006/main" xmlns:r="http://schemas.openxmlformats.org/officeDocument/2006/relationships">
   <p:cSld>
     <p:spTree>
@@ -5281,7 +5211,7 @@
                         <a:rPr sz="1400">
                           <a:latin typeface="Arial"/>
                         </a:rPr>
-                        <a:t>Common master agreed; migration planned by firm</a:t>
+                        <a:t>A-E use the common master; Durnesswick migration in progress</a:t>
                       </a:r>
                     </a:p>
                   </a:txBody>
@@ -5592,7 +5522,7 @@
               <a:rPr sz="2000">
                 <a:latin typeface="Arial"/>
               </a:rPr>
-              <a:t>Durnesswick joined the group on 1 February 2024 and is the first firm to join under the programme</a:t>
+              <a:t>Durnesswick joined the group on 1 February 2024; the acquisition prompted the formal integration programme</a:t>
             </a:r>
           </a:p>
           <a:p>
@@ -5610,7 +5540,7 @@
               <a:rPr sz="2000">
                 <a:latin typeface="Arial"/>
               </a:rPr>
-              <a:t>Brand migration to the common master is the next visible step, and is planned for the second half of the year</a:t>
+              <a:t>Brand migration to the common master remains in progress; confirm outstanding adoption steps with Durnesswick leadership</a:t>
             </a:r>
           </a:p>
           <a:p>
@@ -5788,7 +5718,7 @@
               <a:rPr sz="2000">
                 <a:latin typeface="Arial"/>
               </a:rPr>
-              <a:t>Firms A to E are sequenced for migration, starting with client-facing templates</a:t>
+              <a:t>Firms A to E already use the common master introduced in 2020; Durnesswick is the remaining brand migration workstream</a:t>
             </a:r>
           </a:p>
           <a:p>

</xml_diff>